<commit_message>
docs: update manual formats (DOCX, PDF, PPTX, MD) to v4.8 to include MS Teams notification guides
</commit_message>
<xml_diff>
--- a/溫度通報/溫度通報系統操作說明.pptx
+++ b/溫度通報/溫度通報系統操作說明.pptx
@@ -17,6 +17,7 @@
     <p:sldId id="265" r:id="rId16"/>
     <p:sldId id="266" r:id="rId17"/>
     <p:sldId id="267" r:id="rId18"/>
+    <p:sldId id="268" r:id="rId19"/>
   </p:sldIdLst>
   <p:sldSz cx="12191695" cy="6858000" type="screen4x3"/>
   <p:notesSz cx="6858000" cy="9144000"/>
@@ -4098,6 +4099,243 @@
             </a:pPr>
             <a:r>
               <a:t>• HMI 功能相容性修正：修正全域變數重複宣告 JS 語法錯誤，並加入 Cache-busting 資源載入（v4.6 版本），徹底修復歷史查詢無反應問題。</a:t>
+            </a:r>
+          </a:p>
+        </p:txBody>
+      </p:sp>
+    </p:spTree>
+  </p:cSld>
+  <p:clrMapOvr>
+    <a:masterClrMapping/>
+  </p:clrMapOvr>
+</p:sld>
+</file>
+
+<file path=ppt/slides/slide13.xml><?xml version="1.0" encoding="utf-8"?>
+<p:sld xmlns:a="http://schemas.openxmlformats.org/drawingml/2006/main" xmlns:p="http://schemas.openxmlformats.org/presentationml/2006/main" xmlns:r="http://schemas.openxmlformats.org/officeDocument/2006/relationships">
+  <p:cSld>
+    <p:bg>
+      <p:bgPr>
+        <a:solidFill>
+          <a:srgbClr val="0F172A"/>
+        </a:solidFill>
+        <a:effectLst/>
+      </p:bgPr>
+    </p:bg>
+    <p:spTree>
+      <p:nvGrpSpPr>
+        <p:cNvPr id="1" name=""/>
+        <p:cNvGrpSpPr/>
+        <p:nvPr/>
+      </p:nvGrpSpPr>
+      <p:grpSpPr/>
+      <p:sp>
+        <p:nvSpPr>
+          <p:cNvPr id="2" name="TextBox 1"/>
+          <p:cNvSpPr txBox="1"/>
+          <p:nvPr/>
+        </p:nvSpPr>
+        <p:spPr>
+          <a:xfrm>
+            <a:off x="548640" y="365760"/>
+            <a:ext cx="11091672" cy="731520"/>
+          </a:xfrm>
+          <a:prstGeom prst="rect">
+            <a:avLst/>
+          </a:prstGeom>
+          <a:noFill/>
+        </p:spPr>
+        <p:txBody>
+          <a:bodyPr wrap="square" lIns="0" tIns="0" bIns="0" rIns="0">
+            <a:spAutoFit/>
+          </a:bodyPr>
+          <a:lstStyle/>
+          <a:p>
+            <a:pPr>
+              <a:defRPr sz="3000" b="1">
+                <a:solidFill>
+                  <a:srgbClr val="FFFFFF"/>
+                </a:solidFill>
+                <a:latin typeface="Microsoft JhengHei"/>
+              </a:defRPr>
+            </a:pPr>
+            <a:r>
+              <a:t>🆕 v4.8 版本更新摘要</a:t>
+            </a:r>
+          </a:p>
+        </p:txBody>
+      </p:sp>
+      <p:sp>
+        <p:nvSpPr>
+          <p:cNvPr id="3" name="Rectangle 2"/>
+          <p:cNvSpPr/>
+          <p:nvPr/>
+        </p:nvSpPr>
+        <p:spPr>
+          <a:xfrm>
+            <a:off x="548640" y="1097280"/>
+            <a:ext cx="1828800" cy="54864"/>
+          </a:xfrm>
+          <a:prstGeom prst="rect">
+            <a:avLst/>
+          </a:prstGeom>
+          <a:solidFill>
+            <a:srgbClr val="22D3EE"/>
+          </a:solidFill>
+          <a:ln>
+            <a:noFill/>
+          </a:ln>
+        </p:spPr>
+        <p:style>
+          <a:lnRef idx="1">
+            <a:schemeClr val="accent1"/>
+          </a:lnRef>
+          <a:fillRef idx="3">
+            <a:schemeClr val="accent1"/>
+          </a:fillRef>
+          <a:effectRef idx="2">
+            <a:schemeClr val="accent1"/>
+          </a:effectRef>
+          <a:fontRef idx="minor">
+            <a:schemeClr val="lt1"/>
+          </a:fontRef>
+        </p:style>
+        <p:txBody>
+          <a:bodyPr rtlCol="0" anchor="ctr"/>
+          <a:lstStyle/>
+          <a:p>
+            <a:pPr algn="ctr"/>
+          </a:p>
+        </p:txBody>
+      </p:sp>
+      <p:sp>
+        <p:nvSpPr>
+          <p:cNvPr id="4" name="Rounded Rectangle 3"/>
+          <p:cNvSpPr/>
+          <p:nvPr/>
+        </p:nvSpPr>
+        <p:spPr>
+          <a:xfrm>
+            <a:off x="548640" y="1463040"/>
+            <a:ext cx="10972800" cy="4754880"/>
+          </a:xfrm>
+          <a:prstGeom prst="roundRect">
+            <a:avLst/>
+          </a:prstGeom>
+          <a:solidFill>
+            <a:srgbClr val="1E293B"/>
+          </a:solidFill>
+          <a:ln w="12700">
+            <a:solidFill>
+              <a:srgbClr val="334155"/>
+            </a:solidFill>
+          </a:ln>
+        </p:spPr>
+        <p:style>
+          <a:lnRef idx="1">
+            <a:schemeClr val="accent1"/>
+          </a:lnRef>
+          <a:fillRef idx="3">
+            <a:schemeClr val="accent1"/>
+          </a:fillRef>
+          <a:effectRef idx="2">
+            <a:schemeClr val="accent1"/>
+          </a:effectRef>
+          <a:fontRef idx="minor">
+            <a:schemeClr val="lt1"/>
+          </a:fontRef>
+        </p:style>
+        <p:txBody>
+          <a:bodyPr rtlCol="0" anchor="ctr"/>
+          <a:lstStyle/>
+          <a:p>
+            <a:pPr algn="ctr"/>
+          </a:p>
+        </p:txBody>
+      </p:sp>
+      <p:sp>
+        <p:nvSpPr>
+          <p:cNvPr id="5" name="TextBox 4"/>
+          <p:cNvSpPr txBox="1"/>
+          <p:nvPr/>
+        </p:nvSpPr>
+        <p:spPr>
+          <a:xfrm>
+            <a:off x="731520" y="1645920"/>
+            <a:ext cx="10607040" cy="4389120"/>
+          </a:xfrm>
+          <a:prstGeom prst="rect">
+            <a:avLst/>
+          </a:prstGeom>
+          <a:noFill/>
+        </p:spPr>
+        <p:txBody>
+          <a:bodyPr wrap="square">
+            <a:spAutoFit/>
+          </a:bodyPr>
+          <a:lstStyle/>
+          <a:p>
+            <a:pPr>
+              <a:spcAft>
+                <a:spcPts val="1500"/>
+              </a:spcAft>
+              <a:defRPr sz="2000" b="1">
+                <a:solidFill>
+                  <a:srgbClr val="22D3EE"/>
+                </a:solidFill>
+                <a:latin typeface="Microsoft JhengHei"/>
+              </a:defRPr>
+            </a:pPr>
+            <a:r>
+              <a:t>🆕 系統 v4.8 新增與修改亮點</a:t>
+            </a:r>
+          </a:p>
+          <a:p>
+            <a:pPr>
+              <a:spcAft>
+                <a:spcPts val="1000"/>
+              </a:spcAft>
+              <a:defRPr sz="1400">
+                <a:solidFill>
+                  <a:srgbClr val="FFFFFF"/>
+                </a:solidFill>
+                <a:latin typeface="Microsoft JhengHei"/>
+              </a:defRPr>
+            </a:pPr>
+            <a:r>
+              <a:t>• 新增 Microsoft Teams Webhook 通報：本機 Python 程式與雲端 GAS 備援程式皆已支援發送高溫與回落警報至 Teams 頻道。</a:t>
+            </a:r>
+          </a:p>
+          <a:p>
+            <a:pPr>
+              <a:spcAft>
+                <a:spcPts val="1000"/>
+              </a:spcAft>
+              <a:defRPr sz="1400">
+                <a:solidFill>
+                  <a:srgbClr val="FFFFFF"/>
+                </a:solidFill>
+                <a:latin typeface="Microsoft JhengHei"/>
+              </a:defRPr>
+            </a:pPr>
+            <a:r>
+              <a:t>• 試算表設定檔動態載入：雲端 GAS 支援從「系統設定」工作表動態讀取「Teams Webhook URL」，免修改程式即可更新網址。</a:t>
+            </a:r>
+          </a:p>
+          <a:p>
+            <a:pPr>
+              <a:spcAft>
+                <a:spcPts val="1000"/>
+              </a:spcAft>
+              <a:defRPr sz="1400">
+                <a:solidFill>
+                  <a:srgbClr val="FFFFFF"/>
+                </a:solidFill>
+                <a:latin typeface="Microsoft JhengHei"/>
+              </a:defRPr>
+            </a:pPr>
+            <a:r>
+              <a:t>• MessageCard 卡片美化：傳送至 Teams 頻道的訊息採用結構化 MessageCard 設計，高溫警報以紅色警示，正常回落以綠色標示。</a:t>
             </a:r>
           </a:p>
         </p:txBody>

</xml_diff>

<commit_message>
feat: support monthly 24-hour temperature records tab on Google Sheet and update manuals to v4.9
</commit_message>
<xml_diff>
--- a/溫度通報/溫度通報系統操作說明.pptx
+++ b/溫度通報/溫度通報系統操作說明.pptx
@@ -18,6 +18,7 @@
     <p:sldId id="266" r:id="rId17"/>
     <p:sldId id="267" r:id="rId18"/>
     <p:sldId id="268" r:id="rId19"/>
+    <p:sldId id="269" r:id="rId20"/>
   </p:sldIdLst>
   <p:sldSz cx="12191695" cy="6858000" type="screen4x3"/>
   <p:notesSz cx="6858000" cy="9144000"/>
@@ -4336,6 +4337,227 @@
             </a:pPr>
             <a:r>
               <a:t>• MessageCard 卡片美化：傳送至 Teams 頻道的訊息採用結構化 MessageCard 設計，高溫警報以紅色警示，正常回落以綠色標示。</a:t>
+            </a:r>
+          </a:p>
+        </p:txBody>
+      </p:sp>
+    </p:spTree>
+  </p:cSld>
+  <p:clrMapOvr>
+    <a:masterClrMapping/>
+  </p:clrMapOvr>
+</p:sld>
+</file>
+
+<file path=ppt/slides/slide14.xml><?xml version="1.0" encoding="utf-8"?>
+<p:sld xmlns:a="http://schemas.openxmlformats.org/drawingml/2006/main" xmlns:p="http://schemas.openxmlformats.org/presentationml/2006/main" xmlns:r="http://schemas.openxmlformats.org/officeDocument/2006/relationships">
+  <p:cSld>
+    <p:bg>
+      <p:bgPr>
+        <a:solidFill>
+          <a:srgbClr val="0F172A"/>
+        </a:solidFill>
+        <a:effectLst/>
+      </p:bgPr>
+    </p:bg>
+    <p:spTree>
+      <p:nvGrpSpPr>
+        <p:cNvPr id="1" name=""/>
+        <p:cNvGrpSpPr/>
+        <p:nvPr/>
+      </p:nvGrpSpPr>
+      <p:grpSpPr/>
+      <p:sp>
+        <p:nvSpPr>
+          <p:cNvPr id="2" name="TextBox 1"/>
+          <p:cNvSpPr txBox="1"/>
+          <p:nvPr/>
+        </p:nvSpPr>
+        <p:spPr>
+          <a:xfrm>
+            <a:off x="548640" y="365760"/>
+            <a:ext cx="11091672" cy="731520"/>
+          </a:xfrm>
+          <a:prstGeom prst="rect">
+            <a:avLst/>
+          </a:prstGeom>
+          <a:noFill/>
+        </p:spPr>
+        <p:txBody>
+          <a:bodyPr wrap="square" lIns="0" tIns="0" bIns="0" rIns="0">
+            <a:spAutoFit/>
+          </a:bodyPr>
+          <a:lstStyle/>
+          <a:p>
+            <a:pPr>
+              <a:defRPr sz="3000" b="1">
+                <a:solidFill>
+                  <a:srgbClr val="FFFFFF"/>
+                </a:solidFill>
+                <a:latin typeface="Microsoft JhengHei"/>
+              </a:defRPr>
+            </a:pPr>
+            <a:r>
+              <a:t>🆕 v4.9 版本更新摘要</a:t>
+            </a:r>
+          </a:p>
+        </p:txBody>
+      </p:sp>
+      <p:sp>
+        <p:nvSpPr>
+          <p:cNvPr id="3" name="Rectangle 2"/>
+          <p:cNvSpPr/>
+          <p:nvPr/>
+        </p:nvSpPr>
+        <p:spPr>
+          <a:xfrm>
+            <a:off x="548640" y="1097280"/>
+            <a:ext cx="1828800" cy="54864"/>
+          </a:xfrm>
+          <a:prstGeom prst="rect">
+            <a:avLst/>
+          </a:prstGeom>
+          <a:solidFill>
+            <a:srgbClr val="22D3EE"/>
+          </a:solidFill>
+          <a:ln>
+            <a:noFill/>
+          </a:ln>
+        </p:spPr>
+        <p:style>
+          <a:lnRef idx="1">
+            <a:schemeClr val="accent1"/>
+          </a:lnRef>
+          <a:fillRef idx="3">
+            <a:schemeClr val="accent1"/>
+          </a:fillRef>
+          <a:effectRef idx="2">
+            <a:schemeClr val="accent1"/>
+          </a:effectRef>
+          <a:fontRef idx="minor">
+            <a:schemeClr val="lt1"/>
+          </a:fontRef>
+        </p:style>
+        <p:txBody>
+          <a:bodyPr rtlCol="0" anchor="ctr"/>
+          <a:lstStyle/>
+          <a:p>
+            <a:pPr algn="ctr"/>
+          </a:p>
+        </p:txBody>
+      </p:sp>
+      <p:sp>
+        <p:nvSpPr>
+          <p:cNvPr id="4" name="Rounded Rectangle 3"/>
+          <p:cNvSpPr/>
+          <p:nvPr/>
+        </p:nvSpPr>
+        <p:spPr>
+          <a:xfrm>
+            <a:off x="548640" y="1463040"/>
+            <a:ext cx="10972800" cy="4754880"/>
+          </a:xfrm>
+          <a:prstGeom prst="roundRect">
+            <a:avLst/>
+          </a:prstGeom>
+          <a:solidFill>
+            <a:srgbClr val="1E293B"/>
+          </a:solidFill>
+          <a:ln w="12700">
+            <a:solidFill>
+              <a:srgbClr val="334155"/>
+            </a:solidFill>
+          </a:ln>
+        </p:spPr>
+        <p:style>
+          <a:lnRef idx="1">
+            <a:schemeClr val="accent1"/>
+          </a:lnRef>
+          <a:fillRef idx="3">
+            <a:schemeClr val="accent1"/>
+          </a:fillRef>
+          <a:effectRef idx="2">
+            <a:schemeClr val="accent1"/>
+          </a:effectRef>
+          <a:fontRef idx="minor">
+            <a:schemeClr val="lt1"/>
+          </a:fontRef>
+        </p:style>
+        <p:txBody>
+          <a:bodyPr rtlCol="0" anchor="ctr"/>
+          <a:lstStyle/>
+          <a:p>
+            <a:pPr algn="ctr"/>
+          </a:p>
+        </p:txBody>
+      </p:sp>
+      <p:sp>
+        <p:nvSpPr>
+          <p:cNvPr id="5" name="TextBox 4"/>
+          <p:cNvSpPr txBox="1"/>
+          <p:nvPr/>
+        </p:nvSpPr>
+        <p:spPr>
+          <a:xfrm>
+            <a:off x="731520" y="1645920"/>
+            <a:ext cx="10607040" cy="4389120"/>
+          </a:xfrm>
+          <a:prstGeom prst="rect">
+            <a:avLst/>
+          </a:prstGeom>
+          <a:noFill/>
+        </p:spPr>
+        <p:txBody>
+          <a:bodyPr wrap="square">
+            <a:spAutoFit/>
+          </a:bodyPr>
+          <a:lstStyle/>
+          <a:p>
+            <a:pPr>
+              <a:spcAft>
+                <a:spcPts val="1500"/>
+              </a:spcAft>
+              <a:defRPr sz="2000" b="1">
+                <a:solidFill>
+                  <a:srgbClr val="22D3EE"/>
+                </a:solidFill>
+                <a:latin typeface="Microsoft JhengHei"/>
+              </a:defRPr>
+            </a:pPr>
+            <a:r>
+              <a:t>🆕 系統 v4.9 新增與修改亮點</a:t>
+            </a:r>
+          </a:p>
+          <a:p>
+            <a:pPr>
+              <a:spcAft>
+                <a:spcPts val="1000"/>
+              </a:spcAft>
+              <a:defRPr sz="1400">
+                <a:solidFill>
+                  <a:srgbClr val="FFFFFF"/>
+                </a:solidFill>
+                <a:latin typeface="Microsoft JhengHei"/>
+              </a:defRPr>
+            </a:pPr>
+            <a:r>
+              <a:t>• 獨立的月度 24 小時記錄分頁：雲端 Apps Script 重構日誌寫入路由，日常每 10 分鐘心跳與溫度觀測，自動分流寫入「X月-24小時記錄」分頁，避免主通報紀錄分頁被洗版。</a:t>
+            </a:r>
+          </a:p>
+          <a:p>
+            <a:pPr>
+              <a:spcAft>
+                <a:spcPts val="1000"/>
+              </a:spcAft>
+              <a:defRPr sz="1400">
+                <a:solidFill>
+                  <a:srgbClr val="FFFFFF"/>
+                </a:solidFill>
+                <a:latin typeface="Microsoft JhengHei"/>
+              </a:defRPr>
+            </a:pPr>
+            <a:r>
+              <a:t>• 專屬綠色系排版風格：針對「24小時記錄」分頁套用專屬的深綠色主題表頭（#2E7D32）與排版格式，利於視覺區分，畫面更乾淨整潔。</a:t>
             </a:r>
           </a:p>
         </p:txBody>

</xml_diff>

<commit_message>
fix: rename 24-hour log sheetName to 24小時紀錄_YYYY-MM format and remove sheet.getName prefix in notifications
</commit_message>
<xml_diff>
--- a/溫度通報/溫度通報系統操作說明.pptx
+++ b/溫度通報/溫度通報系統操作說明.pptx
@@ -4541,7 +4541,7 @@
               </a:defRPr>
             </a:pPr>
             <a:r>
-              <a:t>• 獨立的月度 24 小時記錄分頁：雲端 Apps Script 重構日誌寫入路由，日常每 10 分鐘心跳與溫度觀測，自動分流寫入「YYYY年X月-24小時記錄」分頁，避免主通報紀錄分頁被洗版且能完美防範跨年度名稱衝突。</a:t>
+              <a:t>• 獨立的月度 24 小時記錄分頁：雲端 Apps Script 重構日誌寫入路由，日常每 10 分鐘心跳與溫度觀測，自動分流寫入「24小時紀錄_YYYY-MM」分頁，與通報紀錄統一採用西元命名，完美防範跨年度名稱衝突。</a:t>
             </a:r>
           </a:p>
           <a:p>
@@ -4558,6 +4558,22 @@
             </a:pPr>
             <a:r>
               <a:t>• 專屬綠色系排版風格：針對「24小時記錄」分頁套用專屬的深綠色主題表頭（#2E7D32）與排版格式，利於視覺區分，畫面更乾淨整潔。</a:t>
+            </a:r>
+          </a:p>
+          <a:p>
+            <a:pPr>
+              <a:spcAft>
+                <a:spcPts val="1000"/>
+              </a:spcAft>
+              <a:defRPr sz="1400">
+                <a:solidFill>
+                  <a:srgbClr val="FFFFFF"/>
+                </a:solidFill>
+                <a:latin typeface="Microsoft JhengHei"/>
+              </a:defRPr>
+            </a:pPr>
+            <a:r>
+              <a:t>• 警報標題格式優化：移除了警報內文前的試算表分頁名稱字串，使 LINE/Email 通報標題更直接美觀。</a:t>
             </a:r>
           </a:p>
         </p:txBody>

</xml_diff>